<commit_message>
Human deck: replace work plan with layered architecture, polish design
Co-authored-by: arena-agent <297053741+arena-agent@users.noreply.github.com>
</commit_message>
<xml_diff>
--- a/uhi-ppt/HeatSight_UHI_PPT_Human.pptx
+++ b/uhi-ppt/HeatSight_UHI_PPT_Human.pptx
@@ -1314,7 +1314,7 @@
           <a:lstStyle/>
           <a:p>
             <a:r>
-              <a:t>Show the plan is realistic: one city first, then repeat. Mentioning the monsoon/cloud difficulty shows maturity.</a:t>
+              <a:t>Explain the three layers: what data comes in, what the model does, what the planner gets. Mention the build-order line at the bottom.</a:t>
             </a:r>
           </a:p>
         </p:txBody>
@@ -4603,14 +4603,102 @@
       </p:sp>
       <p:sp>
         <p:nvSpPr>
-          <p:cNvPr id="7" name="TextBox 6"/>
+          <p:cNvPr id="7" name="Rectangle 6"/>
+          <p:cNvSpPr/>
+          <p:nvPr/>
+        </p:nvSpPr>
+        <p:spPr>
+          <a:xfrm>
+            <a:off x="822960" y="3401568"/>
+            <a:ext cx="6949440" cy="1417320"/>
+          </a:xfrm>
+          <a:prstGeom prst="rect">
+            <a:avLst/>
+          </a:prstGeom>
+          <a:solidFill>
+            <a:srgbClr val="F5F5F5"/>
+          </a:solidFill>
+          <a:ln w="9525">
+            <a:solidFill>
+              <a:srgbClr val="E0E0E0"/>
+            </a:solidFill>
+          </a:ln>
+        </p:spPr>
+        <p:style>
+          <a:lnRef idx="1">
+            <a:schemeClr val="accent1"/>
+          </a:lnRef>
+          <a:fillRef idx="3">
+            <a:schemeClr val="accent1"/>
+          </a:fillRef>
+          <a:effectRef idx="2">
+            <a:schemeClr val="accent1"/>
+          </a:effectRef>
+          <a:fontRef idx="minor">
+            <a:schemeClr val="lt1"/>
+          </a:fontRef>
+        </p:style>
+        <p:txBody>
+          <a:bodyPr rtlCol="0" anchor="ctr"/>
+          <a:lstStyle/>
+          <a:p>
+            <a:pPr algn="ctr"/>
+          </a:p>
+        </p:txBody>
+      </p:sp>
+      <p:sp>
+        <p:nvSpPr>
+          <p:cNvPr id="8" name="Rectangle 7"/>
+          <p:cNvSpPr/>
+          <p:nvPr/>
+        </p:nvSpPr>
+        <p:spPr>
+          <a:xfrm>
+            <a:off x="822960" y="3401568"/>
+            <a:ext cx="64008" cy="1417320"/>
+          </a:xfrm>
+          <a:prstGeom prst="rect">
+            <a:avLst/>
+          </a:prstGeom>
+          <a:solidFill>
+            <a:srgbClr val="A93226"/>
+          </a:solidFill>
+          <a:ln>
+            <a:noFill/>
+          </a:ln>
+        </p:spPr>
+        <p:style>
+          <a:lnRef idx="1">
+            <a:schemeClr val="accent1"/>
+          </a:lnRef>
+          <a:fillRef idx="3">
+            <a:schemeClr val="accent1"/>
+          </a:fillRef>
+          <a:effectRef idx="2">
+            <a:schemeClr val="accent1"/>
+          </a:effectRef>
+          <a:fontRef idx="minor">
+            <a:schemeClr val="lt1"/>
+          </a:fontRef>
+        </p:style>
+        <p:txBody>
+          <a:bodyPr rtlCol="0" anchor="ctr"/>
+          <a:lstStyle/>
+          <a:p>
+            <a:pPr algn="ctr"/>
+          </a:p>
+        </p:txBody>
+      </p:sp>
+      <p:sp>
+        <p:nvSpPr>
+          <p:cNvPr id="9" name="TextBox 8"/>
           <p:cNvSpPr txBox="1"/>
           <p:nvPr/>
         </p:nvSpPr>
         <p:spPr>
           <a:xfrm>
-            <a:off x="822960" y="3474720"/>
-            <a:ext cx="10515600" cy="1463040"/>
+            <a:off x="1143000" y="3547872"/>
+            <a:ext cx="6492240" cy="1188720"/>
           </a:xfrm>
           <a:prstGeom prst="rect">
             <a:avLst/>
@@ -4701,7 +4789,7 @@
       </p:sp>
       <p:sp>
         <p:nvSpPr>
-          <p:cNvPr id="8" name="TextBox 7"/>
+          <p:cNvPr id="10" name="TextBox 9"/>
           <p:cNvSpPr txBox="1"/>
           <p:nvPr/>
         </p:nvSpPr>
@@ -4740,7 +4828,7 @@
       </p:sp>
       <p:sp>
         <p:nvSpPr>
-          <p:cNvPr id="9" name="Rectangle 8"/>
+          <p:cNvPr id="11" name="Rectangle 10"/>
           <p:cNvSpPr/>
           <p:nvPr/>
         </p:nvSpPr>
@@ -4783,7 +4871,7 @@
       </p:sp>
       <p:sp>
         <p:nvSpPr>
-          <p:cNvPr id="10" name="TextBox 9"/>
+          <p:cNvPr id="12" name="TextBox 11"/>
           <p:cNvSpPr txBox="1"/>
           <p:nvPr/>
         </p:nvSpPr>
@@ -4822,7 +4910,7 @@
       </p:sp>
       <p:sp>
         <p:nvSpPr>
-          <p:cNvPr id="11" name="TextBox 10"/>
+          <p:cNvPr id="13" name="TextBox 12"/>
           <p:cNvSpPr txBox="1"/>
           <p:nvPr/>
         </p:nvSpPr>
@@ -8886,7 +8974,7 @@
       </p:sp>
       <p:sp>
         <p:nvSpPr>
-          <p:cNvPr id="9" name="Rectangle 8"/>
+          <p:cNvPr id="9" name="Rounded Rectangle 8"/>
           <p:cNvSpPr/>
           <p:nvPr/>
         </p:nvSpPr>
@@ -8895,7 +8983,7 @@
             <a:off x="731520" y="1828800"/>
             <a:ext cx="1783080" cy="1737360"/>
           </a:xfrm>
-          <a:prstGeom prst="rect">
+          <a:prstGeom prst="roundRect">
             <a:avLst/>
           </a:prstGeom>
           <a:solidFill>
@@ -9050,7 +9138,7 @@
       </p:sp>
       <p:sp>
         <p:nvSpPr>
-          <p:cNvPr id="13" name="Rectangle 12"/>
+          <p:cNvPr id="13" name="Rounded Rectangle 12"/>
           <p:cNvSpPr/>
           <p:nvPr/>
         </p:nvSpPr>
@@ -9059,7 +9147,7 @@
             <a:off x="2971800" y="1828800"/>
             <a:ext cx="1783080" cy="1737360"/>
           </a:xfrm>
-          <a:prstGeom prst="rect">
+          <a:prstGeom prst="roundRect">
             <a:avLst/>
           </a:prstGeom>
           <a:solidFill>
@@ -9214,7 +9302,7 @@
       </p:sp>
       <p:sp>
         <p:nvSpPr>
-          <p:cNvPr id="17" name="Rectangle 16"/>
+          <p:cNvPr id="17" name="Rounded Rectangle 16"/>
           <p:cNvSpPr/>
           <p:nvPr/>
         </p:nvSpPr>
@@ -9223,7 +9311,7 @@
             <a:off x="5212080" y="1828800"/>
             <a:ext cx="1783080" cy="1737360"/>
           </a:xfrm>
-          <a:prstGeom prst="rect">
+          <a:prstGeom prst="roundRect">
             <a:avLst/>
           </a:prstGeom>
           <a:solidFill>
@@ -9378,7 +9466,7 @@
       </p:sp>
       <p:sp>
         <p:nvSpPr>
-          <p:cNvPr id="21" name="Rectangle 20"/>
+          <p:cNvPr id="21" name="Rounded Rectangle 20"/>
           <p:cNvSpPr/>
           <p:nvPr/>
         </p:nvSpPr>
@@ -9387,7 +9475,7 @@
             <a:off x="7452360" y="1828800"/>
             <a:ext cx="1783080" cy="1737360"/>
           </a:xfrm>
-          <a:prstGeom prst="rect">
+          <a:prstGeom prst="roundRect">
             <a:avLst/>
           </a:prstGeom>
           <a:solidFill>
@@ -9542,7 +9630,7 @@
       </p:sp>
       <p:sp>
         <p:nvSpPr>
-          <p:cNvPr id="25" name="Rectangle 24"/>
+          <p:cNvPr id="25" name="Rounded Rectangle 24"/>
           <p:cNvSpPr/>
           <p:nvPr/>
         </p:nvSpPr>
@@ -9551,7 +9639,7 @@
             <a:off x="9692640" y="1828800"/>
             <a:ext cx="1783080" cy="1737360"/>
           </a:xfrm>
-          <a:prstGeom prst="rect">
+          <a:prstGeom prst="roundRect">
             <a:avLst/>
           </a:prstGeom>
           <a:solidFill>
@@ -11714,7 +11802,7 @@
                 </a:solidFill>
                 <a:latin typeface="Calibri"/>
               </a:rPr>
-              <a:t>Work plan</a:t>
+              <a:t>System architecture</a:t>
             </a:r>
           </a:p>
         </p:txBody>
@@ -11753,7 +11841,7 @@
                 </a:solidFill>
                 <a:latin typeface="Calibri"/>
               </a:rPr>
-              <a:t>How we will build this step by step (pilot: one city first)</a:t>
+              <a:t>How the parts connect — satellite data in, planning decisions out</a:t>
             </a:r>
           </a:p>
         </p:txBody>
@@ -11965,852 +12053,16 @@
           </a:p>
         </p:txBody>
       </p:sp>
-      <p:graphicFrame>
-        <p:nvGraphicFramePr>
-          <p:cNvPr id="9" name="Table 8"/>
-          <p:cNvGraphicFramePr>
-            <a:graphicFrameLocks noGrp="1"/>
-          </p:cNvGraphicFramePr>
-          <p:nvPr/>
-        </p:nvGraphicFramePr>
-        <p:xfrm>
-          <a:off x="731520" y="1783080"/>
-          <a:ext cx="10725912" cy="3200400"/>
-        </p:xfrm>
-        <a:graphic>
-          <a:graphicData uri="http://schemas.openxmlformats.org/drawingml/2006/table">
-            <a:tbl>
-              <a:tblPr firstRow="1" bandRow="1">
-                <a:tableStyleId>{5C22544A-7EE6-4342-B048-85BDC9FD1C3A}</a:tableStyleId>
-              </a:tblPr>
-              <a:tblGrid>
-                <a:gridCol w="1005840"/>
-                <a:gridCol w="1188720"/>
-                <a:gridCol w="4754880"/>
-                <a:gridCol w="3776472"/>
-              </a:tblGrid>
-              <a:tr h="640080">
-                <a:tc>
-                  <a:txBody>
-                    <a:bodyPr/>
-                    <a:lstStyle/>
-                    <a:p>
-                      <a:pPr>
-                        <a:spcAft>
-                          <a:spcPts val="100"/>
-                        </a:spcAft>
-                      </a:pPr>
-                      <a:r>
-                        <a:rPr sz="1250" b="1">
-                          <a:solidFill>
-                            <a:srgbClr val="212121"/>
-                          </a:solidFill>
-                          <a:latin typeface="Calibri"/>
-                        </a:rPr>
-                        <a:t>Phase</a:t>
-                      </a:r>
-                    </a:p>
-                  </a:txBody>
-                  <a:tcPr anchor="ctr" marL="91440" marR="73152" marT="36576" marB="36576">
-                    <a:solidFill>
-                      <a:srgbClr val="E8E8E8"/>
-                    </a:solidFill>
-                  </a:tcPr>
-                </a:tc>
-                <a:tc>
-                  <a:txBody>
-                    <a:bodyPr/>
-                    <a:lstStyle/>
-                    <a:p>
-                      <a:pPr>
-                        <a:spcAft>
-                          <a:spcPts val="100"/>
-                        </a:spcAft>
-                      </a:pPr>
-                      <a:r>
-                        <a:rPr sz="1250" b="1">
-                          <a:solidFill>
-                            <a:srgbClr val="212121"/>
-                          </a:solidFill>
-                          <a:latin typeface="Calibri"/>
-                        </a:rPr>
-                        <a:t>Time</a:t>
-                      </a:r>
-                    </a:p>
-                  </a:txBody>
-                  <a:tcPr anchor="ctr" marL="91440" marR="73152" marT="36576" marB="36576">
-                    <a:solidFill>
-                      <a:srgbClr val="E8E8E8"/>
-                    </a:solidFill>
-                  </a:tcPr>
-                </a:tc>
-                <a:tc>
-                  <a:txBody>
-                    <a:bodyPr/>
-                    <a:lstStyle/>
-                    <a:p>
-                      <a:pPr>
-                        <a:spcAft>
-                          <a:spcPts val="100"/>
-                        </a:spcAft>
-                      </a:pPr>
-                      <a:r>
-                        <a:rPr sz="1250" b="1">
-                          <a:solidFill>
-                            <a:srgbClr val="212121"/>
-                          </a:solidFill>
-                          <a:latin typeface="Calibri"/>
-                        </a:rPr>
-                        <a:t>Work</a:t>
-                      </a:r>
-                    </a:p>
-                  </a:txBody>
-                  <a:tcPr anchor="ctr" marL="91440" marR="73152" marT="36576" marB="36576">
-                    <a:solidFill>
-                      <a:srgbClr val="E8E8E8"/>
-                    </a:solidFill>
-                  </a:tcPr>
-                </a:tc>
-                <a:tc>
-                  <a:txBody>
-                    <a:bodyPr/>
-                    <a:lstStyle/>
-                    <a:p>
-                      <a:pPr>
-                        <a:spcAft>
-                          <a:spcPts val="100"/>
-                        </a:spcAft>
-                      </a:pPr>
-                      <a:r>
-                        <a:rPr sz="1250" b="1">
-                          <a:solidFill>
-                            <a:srgbClr val="212121"/>
-                          </a:solidFill>
-                          <a:latin typeface="Calibri"/>
-                        </a:rPr>
-                        <a:t>Outcome</a:t>
-                      </a:r>
-                    </a:p>
-                  </a:txBody>
-                  <a:tcPr anchor="ctr" marL="91440" marR="73152" marT="36576" marB="36576">
-                    <a:solidFill>
-                      <a:srgbClr val="E8E8E8"/>
-                    </a:solidFill>
-                  </a:tcPr>
-                </a:tc>
-              </a:tr>
-              <a:tr h="640080">
-                <a:tc>
-                  <a:txBody>
-                    <a:bodyPr/>
-                    <a:lstStyle/>
-                    <a:p>
-                      <a:pPr>
-                        <a:spcAft>
-                          <a:spcPts val="100"/>
-                        </a:spcAft>
-                      </a:pPr>
-                      <a:r>
-                        <a:rPr sz="1200" b="1">
-                          <a:solidFill>
-                            <a:srgbClr val="212121"/>
-                          </a:solidFill>
-                          <a:latin typeface="Calibri"/>
-                        </a:rPr>
-                        <a:t>1. Data</a:t>
-                      </a:r>
-                    </a:p>
-                  </a:txBody>
-                  <a:tcPr anchor="ctr" marL="91440" marR="73152" marT="36576" marB="36576">
-                    <a:solidFill>
-                      <a:srgbClr val="FFFFFF"/>
-                    </a:solidFill>
-                  </a:tcPr>
-                </a:tc>
-                <a:tc>
-                  <a:txBody>
-                    <a:bodyPr/>
-                    <a:lstStyle/>
-                    <a:p>
-                      <a:pPr>
-                        <a:spcAft>
-                          <a:spcPts val="100"/>
-                        </a:spcAft>
-                      </a:pPr>
-                      <a:r>
-                        <a:rPr sz="1200" b="0">
-                          <a:solidFill>
-                            <a:srgbClr val="212121"/>
-                          </a:solidFill>
-                          <a:latin typeface="Calibri"/>
-                        </a:rPr>
-                        <a:t>Week 1–2</a:t>
-                      </a:r>
-                    </a:p>
-                  </a:txBody>
-                  <a:tcPr anchor="ctr" marL="91440" marR="73152" marT="36576" marB="36576">
-                    <a:solidFill>
-                      <a:srgbClr val="FFFFFF"/>
-                    </a:solidFill>
-                  </a:tcPr>
-                </a:tc>
-                <a:tc>
-                  <a:txBody>
-                    <a:bodyPr/>
-                    <a:lstStyle/>
-                    <a:p>
-                      <a:pPr>
-                        <a:spcAft>
-                          <a:spcPts val="100"/>
-                        </a:spcAft>
-                      </a:pPr>
-                      <a:r>
-                        <a:rPr sz="1200" b="0">
-                          <a:solidFill>
-                            <a:srgbClr val="212121"/>
-                          </a:solidFill>
-                          <a:latin typeface="Calibri"/>
-                        </a:rPr>
-                        <a:t>Collect Landsat + Sentinel-2 data on GEE; prepare ward maps</a:t>
-                      </a:r>
-                    </a:p>
-                  </a:txBody>
-                  <a:tcPr anchor="ctr" marL="91440" marR="73152" marT="36576" marB="36576">
-                    <a:solidFill>
-                      <a:srgbClr val="FFFFFF"/>
-                    </a:solidFill>
-                  </a:tcPr>
-                </a:tc>
-                <a:tc>
-                  <a:txBody>
-                    <a:bodyPr/>
-                    <a:lstStyle/>
-                    <a:p>
-                      <a:pPr>
-                        <a:spcAft>
-                          <a:spcPts val="100"/>
-                        </a:spcAft>
-                      </a:pPr>
-                      <a:r>
-                        <a:rPr sz="1200" b="0">
-                          <a:solidFill>
-                            <a:srgbClr val="212121"/>
-                          </a:solidFill>
-                          <a:latin typeface="Calibri"/>
-                        </a:rPr>
-                        <a:t>Clean 10-year heat dataset</a:t>
-                      </a:r>
-                    </a:p>
-                  </a:txBody>
-                  <a:tcPr anchor="ctr" marL="91440" marR="73152" marT="36576" marB="36576">
-                    <a:solidFill>
-                      <a:srgbClr val="FFFFFF"/>
-                    </a:solidFill>
-                  </a:tcPr>
-                </a:tc>
-              </a:tr>
-              <a:tr h="640080">
-                <a:tc>
-                  <a:txBody>
-                    <a:bodyPr/>
-                    <a:lstStyle/>
-                    <a:p>
-                      <a:pPr>
-                        <a:spcAft>
-                          <a:spcPts val="100"/>
-                        </a:spcAft>
-                      </a:pPr>
-                      <a:r>
-                        <a:rPr sz="1200" b="1">
-                          <a:solidFill>
-                            <a:srgbClr val="212121"/>
-                          </a:solidFill>
-                          <a:latin typeface="Calibri"/>
-                        </a:rPr>
-                        <a:t>2. Model</a:t>
-                      </a:r>
-                    </a:p>
-                  </a:txBody>
-                  <a:tcPr anchor="ctr" marL="91440" marR="73152" marT="36576" marB="36576">
-                    <a:solidFill>
-                      <a:srgbClr val="FFFFFF"/>
-                    </a:solidFill>
-                  </a:tcPr>
-                </a:tc>
-                <a:tc>
-                  <a:txBody>
-                    <a:bodyPr/>
-                    <a:lstStyle/>
-                    <a:p>
-                      <a:pPr>
-                        <a:spcAft>
-                          <a:spcPts val="100"/>
-                        </a:spcAft>
-                      </a:pPr>
-                      <a:r>
-                        <a:rPr sz="1200" b="0">
-                          <a:solidFill>
-                            <a:srgbClr val="212121"/>
-                          </a:solidFill>
-                          <a:latin typeface="Calibri"/>
-                        </a:rPr>
-                        <a:t>Week 3–4</a:t>
-                      </a:r>
-                    </a:p>
-                  </a:txBody>
-                  <a:tcPr anchor="ctr" marL="91440" marR="73152" marT="36576" marB="36576">
-                    <a:solidFill>
-                      <a:srgbClr val="FFFFFF"/>
-                    </a:solidFill>
-                  </a:tcPr>
-                </a:tc>
-                <a:tc>
-                  <a:txBody>
-                    <a:bodyPr/>
-                    <a:lstStyle/>
-                    <a:p>
-                      <a:pPr>
-                        <a:spcAft>
-                          <a:spcPts val="100"/>
-                        </a:spcAft>
-                      </a:pPr>
-                      <a:r>
-                        <a:rPr sz="1200" b="0">
-                          <a:solidFill>
-                            <a:srgbClr val="212121"/>
-                          </a:solidFill>
-                          <a:latin typeface="Calibri"/>
-                        </a:rPr>
-                        <a:t>Build features; train and test ML model; compare with IMD data</a:t>
-                      </a:r>
-                    </a:p>
-                  </a:txBody>
-                  <a:tcPr anchor="ctr" marL="91440" marR="73152" marT="36576" marB="36576">
-                    <a:solidFill>
-                      <a:srgbClr val="FFFFFF"/>
-                    </a:solidFill>
-                  </a:tcPr>
-                </a:tc>
-                <a:tc>
-                  <a:txBody>
-                    <a:bodyPr/>
-                    <a:lstStyle/>
-                    <a:p>
-                      <a:pPr>
-                        <a:spcAft>
-                          <a:spcPts val="100"/>
-                        </a:spcAft>
-                      </a:pPr>
-                      <a:r>
-                        <a:rPr sz="1200" b="0">
-                          <a:solidFill>
-                            <a:srgbClr val="212121"/>
-                          </a:solidFill>
-                          <a:latin typeface="Calibri"/>
-                        </a:rPr>
-                        <a:t>2030 ward-level forecast</a:t>
-                      </a:r>
-                    </a:p>
-                  </a:txBody>
-                  <a:tcPr anchor="ctr" marL="91440" marR="73152" marT="36576" marB="36576">
-                    <a:solidFill>
-                      <a:srgbClr val="FFFFFF"/>
-                    </a:solidFill>
-                  </a:tcPr>
-                </a:tc>
-              </a:tr>
-              <a:tr h="640080">
-                <a:tc>
-                  <a:txBody>
-                    <a:bodyPr/>
-                    <a:lstStyle/>
-                    <a:p>
-                      <a:pPr>
-                        <a:spcAft>
-                          <a:spcPts val="100"/>
-                        </a:spcAft>
-                      </a:pPr>
-                      <a:r>
-                        <a:rPr sz="1200" b="1">
-                          <a:solidFill>
-                            <a:srgbClr val="212121"/>
-                          </a:solidFill>
-                          <a:latin typeface="Calibri"/>
-                        </a:rPr>
-                        <a:t>3. Outputs</a:t>
-                      </a:r>
-                    </a:p>
-                  </a:txBody>
-                  <a:tcPr anchor="ctr" marL="91440" marR="73152" marT="36576" marB="36576">
-                    <a:solidFill>
-                      <a:srgbClr val="FFFFFF"/>
-                    </a:solidFill>
-                  </a:tcPr>
-                </a:tc>
-                <a:tc>
-                  <a:txBody>
-                    <a:bodyPr/>
-                    <a:lstStyle/>
-                    <a:p>
-                      <a:pPr>
-                        <a:spcAft>
-                          <a:spcPts val="100"/>
-                        </a:spcAft>
-                      </a:pPr>
-                      <a:r>
-                        <a:rPr sz="1200" b="0">
-                          <a:solidFill>
-                            <a:srgbClr val="212121"/>
-                          </a:solidFill>
-                          <a:latin typeface="Calibri"/>
-                        </a:rPr>
-                        <a:t>Week 5–6</a:t>
-                      </a:r>
-                    </a:p>
-                  </a:txBody>
-                  <a:tcPr anchor="ctr" marL="91440" marR="73152" marT="36576" marB="36576">
-                    <a:solidFill>
-                      <a:srgbClr val="FFFFFF"/>
-                    </a:solidFill>
-                  </a:tcPr>
-                </a:tc>
-                <a:tc>
-                  <a:txBody>
-                    <a:bodyPr/>
-                    <a:lstStyle/>
-                    <a:p>
-                      <a:pPr>
-                        <a:spcAft>
-                          <a:spcPts val="100"/>
-                        </a:spcAft>
-                      </a:pPr>
-                      <a:r>
-                        <a:rPr sz="1200" b="0">
-                          <a:solidFill>
-                            <a:srgbClr val="212121"/>
-                          </a:solidFill>
-                          <a:latin typeface="Calibri"/>
-                        </a:rPr>
-                        <a:t>Prepare maps, tables, charts and ward action notes</a:t>
-                      </a:r>
-                    </a:p>
-                  </a:txBody>
-                  <a:tcPr anchor="ctr" marL="91440" marR="73152" marT="36576" marB="36576">
-                    <a:solidFill>
-                      <a:srgbClr val="FFFFFF"/>
-                    </a:solidFill>
-                  </a:tcPr>
-                </a:tc>
-                <a:tc>
-                  <a:txBody>
-                    <a:bodyPr/>
-                    <a:lstStyle/>
-                    <a:p>
-                      <a:pPr>
-                        <a:spcAft>
-                          <a:spcPts val="100"/>
-                        </a:spcAft>
-                      </a:pPr>
-                      <a:r>
-                        <a:rPr sz="1200" b="0">
-                          <a:solidFill>
-                            <a:srgbClr val="212121"/>
-                          </a:solidFill>
-                          <a:latin typeface="Calibri"/>
-                        </a:rPr>
-                        <a:t>Complete pilot report</a:t>
-                      </a:r>
-                    </a:p>
-                  </a:txBody>
-                  <a:tcPr anchor="ctr" marL="91440" marR="73152" marT="36576" marB="36576">
-                    <a:solidFill>
-                      <a:srgbClr val="FFFFFF"/>
-                    </a:solidFill>
-                  </a:tcPr>
-                </a:tc>
-              </a:tr>
-              <a:tr h="640080">
-                <a:tc>
-                  <a:txBody>
-                    <a:bodyPr/>
-                    <a:lstStyle/>
-                    <a:p>
-                      <a:pPr>
-                        <a:spcAft>
-                          <a:spcPts val="100"/>
-                        </a:spcAft>
-                      </a:pPr>
-                      <a:r>
-                        <a:rPr sz="1200" b="1">
-                          <a:solidFill>
-                            <a:srgbClr val="212121"/>
-                          </a:solidFill>
-                          <a:latin typeface="Calibri"/>
-                        </a:rPr>
-                        <a:t>4. Testing</a:t>
-                      </a:r>
-                    </a:p>
-                  </a:txBody>
-                  <a:tcPr anchor="ctr" marL="91440" marR="73152" marT="36576" marB="36576">
-                    <a:solidFill>
-                      <a:srgbClr val="FFFFFF"/>
-                    </a:solidFill>
-                  </a:tcPr>
-                </a:tc>
-                <a:tc>
-                  <a:txBody>
-                    <a:bodyPr/>
-                    <a:lstStyle/>
-                    <a:p>
-                      <a:pPr>
-                        <a:spcAft>
-                          <a:spcPts val="100"/>
-                        </a:spcAft>
-                      </a:pPr>
-                      <a:r>
-                        <a:rPr sz="1200" b="0">
-                          <a:solidFill>
-                            <a:srgbClr val="212121"/>
-                          </a:solidFill>
-                          <a:latin typeface="Calibri"/>
-                        </a:rPr>
-                        <a:t>Week 7+</a:t>
-                      </a:r>
-                    </a:p>
-                  </a:txBody>
-                  <a:tcPr anchor="ctr" marL="91440" marR="73152" marT="36576" marB="36576">
-                    <a:solidFill>
-                      <a:srgbClr val="FFFFFF"/>
-                    </a:solidFill>
-                  </a:tcPr>
-                </a:tc>
-                <a:tc>
-                  <a:txBody>
-                    <a:bodyPr/>
-                    <a:lstStyle/>
-                    <a:p>
-                      <a:pPr>
-                        <a:spcAft>
-                          <a:spcPts val="100"/>
-                        </a:spcAft>
-                      </a:pPr>
-                      <a:r>
-                        <a:rPr sz="1200" b="0">
-                          <a:solidFill>
-                            <a:srgbClr val="212121"/>
-                          </a:solidFill>
-                          <a:latin typeface="Calibri"/>
-                        </a:rPr>
-                        <a:t>Ground checks; extend method to a second city</a:t>
-                      </a:r>
-                    </a:p>
-                  </a:txBody>
-                  <a:tcPr anchor="ctr" marL="91440" marR="73152" marT="36576" marB="36576">
-                    <a:solidFill>
-                      <a:srgbClr val="FFFFFF"/>
-                    </a:solidFill>
-                  </a:tcPr>
-                </a:tc>
-                <a:tc>
-                  <a:txBody>
-                    <a:bodyPr/>
-                    <a:lstStyle/>
-                    <a:p>
-                      <a:pPr>
-                        <a:spcAft>
-                          <a:spcPts val="100"/>
-                        </a:spcAft>
-                      </a:pPr>
-                      <a:r>
-                        <a:rPr sz="1200" b="0">
-                          <a:solidFill>
-                            <a:srgbClr val="212121"/>
-                          </a:solidFill>
-                          <a:latin typeface="Calibri"/>
-                        </a:rPr>
-                        <a:t>Tested, repeatable method</a:t>
-                      </a:r>
-                    </a:p>
-                  </a:txBody>
-                  <a:tcPr anchor="ctr" marL="91440" marR="73152" marT="36576" marB="36576">
-                    <a:solidFill>
-                      <a:srgbClr val="FFFFFF"/>
-                    </a:solidFill>
-                  </a:tcPr>
-                </a:tc>
-              </a:tr>
-            </a:tbl>
-          </a:graphicData>
-        </a:graphic>
-      </p:graphicFrame>
-      <p:sp>
-        <p:nvSpPr>
-          <p:cNvPr id="10" name="Rectangle 9"/>
+      <p:sp>
+        <p:nvSpPr>
+          <p:cNvPr id="9" name="Rectangle 8"/>
           <p:cNvSpPr/>
           <p:nvPr/>
         </p:nvSpPr>
         <p:spPr>
           <a:xfrm>
-            <a:off x="731520" y="2409444"/>
-            <a:ext cx="10725912" cy="13716"/>
-          </a:xfrm>
-          <a:prstGeom prst="rect">
-            <a:avLst/>
-          </a:prstGeom>
-          <a:solidFill>
-            <a:srgbClr val="E0E0E0"/>
-          </a:solidFill>
-          <a:ln>
-            <a:noFill/>
-          </a:ln>
-        </p:spPr>
-        <p:style>
-          <a:lnRef idx="1">
-            <a:schemeClr val="accent1"/>
-          </a:lnRef>
-          <a:fillRef idx="3">
-            <a:schemeClr val="accent1"/>
-          </a:fillRef>
-          <a:effectRef idx="2">
-            <a:schemeClr val="accent1"/>
-          </a:effectRef>
-          <a:fontRef idx="minor">
-            <a:schemeClr val="lt1"/>
-          </a:fontRef>
-        </p:style>
-        <p:txBody>
-          <a:bodyPr rtlCol="0" anchor="ctr"/>
-          <a:lstStyle/>
-          <a:p>
-            <a:pPr algn="ctr"/>
-          </a:p>
-        </p:txBody>
-      </p:sp>
-      <p:sp>
-        <p:nvSpPr>
-          <p:cNvPr id="11" name="Rectangle 10"/>
-          <p:cNvSpPr/>
-          <p:nvPr/>
-        </p:nvSpPr>
-        <p:spPr>
-          <a:xfrm>
-            <a:off x="731520" y="3049524"/>
-            <a:ext cx="10725912" cy="13716"/>
-          </a:xfrm>
-          <a:prstGeom prst="rect">
-            <a:avLst/>
-          </a:prstGeom>
-          <a:solidFill>
-            <a:srgbClr val="E0E0E0"/>
-          </a:solidFill>
-          <a:ln>
-            <a:noFill/>
-          </a:ln>
-        </p:spPr>
-        <p:style>
-          <a:lnRef idx="1">
-            <a:schemeClr val="accent1"/>
-          </a:lnRef>
-          <a:fillRef idx="3">
-            <a:schemeClr val="accent1"/>
-          </a:fillRef>
-          <a:effectRef idx="2">
-            <a:schemeClr val="accent1"/>
-          </a:effectRef>
-          <a:fontRef idx="minor">
-            <a:schemeClr val="lt1"/>
-          </a:fontRef>
-        </p:style>
-        <p:txBody>
-          <a:bodyPr rtlCol="0" anchor="ctr"/>
-          <a:lstStyle/>
-          <a:p>
-            <a:pPr algn="ctr"/>
-          </a:p>
-        </p:txBody>
-      </p:sp>
-      <p:sp>
-        <p:nvSpPr>
-          <p:cNvPr id="12" name="Rectangle 11"/>
-          <p:cNvSpPr/>
-          <p:nvPr/>
-        </p:nvSpPr>
-        <p:spPr>
-          <a:xfrm>
-            <a:off x="731520" y="3689604"/>
-            <a:ext cx="10725912" cy="13716"/>
-          </a:xfrm>
-          <a:prstGeom prst="rect">
-            <a:avLst/>
-          </a:prstGeom>
-          <a:solidFill>
-            <a:srgbClr val="E0E0E0"/>
-          </a:solidFill>
-          <a:ln>
-            <a:noFill/>
-          </a:ln>
-        </p:spPr>
-        <p:style>
-          <a:lnRef idx="1">
-            <a:schemeClr val="accent1"/>
-          </a:lnRef>
-          <a:fillRef idx="3">
-            <a:schemeClr val="accent1"/>
-          </a:fillRef>
-          <a:effectRef idx="2">
-            <a:schemeClr val="accent1"/>
-          </a:effectRef>
-          <a:fontRef idx="minor">
-            <a:schemeClr val="lt1"/>
-          </a:fontRef>
-        </p:style>
-        <p:txBody>
-          <a:bodyPr rtlCol="0" anchor="ctr"/>
-          <a:lstStyle/>
-          <a:p>
-            <a:pPr algn="ctr"/>
-          </a:p>
-        </p:txBody>
-      </p:sp>
-      <p:sp>
-        <p:nvSpPr>
-          <p:cNvPr id="13" name="Rectangle 12"/>
-          <p:cNvSpPr/>
-          <p:nvPr/>
-        </p:nvSpPr>
-        <p:spPr>
-          <a:xfrm>
-            <a:off x="731520" y="4329684"/>
-            <a:ext cx="10725912" cy="13716"/>
-          </a:xfrm>
-          <a:prstGeom prst="rect">
-            <a:avLst/>
-          </a:prstGeom>
-          <a:solidFill>
-            <a:srgbClr val="E0E0E0"/>
-          </a:solidFill>
-          <a:ln>
-            <a:noFill/>
-          </a:ln>
-        </p:spPr>
-        <p:style>
-          <a:lnRef idx="1">
-            <a:schemeClr val="accent1"/>
-          </a:lnRef>
-          <a:fillRef idx="3">
-            <a:schemeClr val="accent1"/>
-          </a:fillRef>
-          <a:effectRef idx="2">
-            <a:schemeClr val="accent1"/>
-          </a:effectRef>
-          <a:fontRef idx="minor">
-            <a:schemeClr val="lt1"/>
-          </a:fontRef>
-        </p:style>
-        <p:txBody>
-          <a:bodyPr rtlCol="0" anchor="ctr"/>
-          <a:lstStyle/>
-          <a:p>
-            <a:pPr algn="ctr"/>
-          </a:p>
-        </p:txBody>
-      </p:sp>
-      <p:sp>
-        <p:nvSpPr>
-          <p:cNvPr id="14" name="Rectangle 13"/>
-          <p:cNvSpPr/>
-          <p:nvPr/>
-        </p:nvSpPr>
-        <p:spPr>
-          <a:xfrm>
-            <a:off x="731520" y="4969764"/>
-            <a:ext cx="10725912" cy="13716"/>
-          </a:xfrm>
-          <a:prstGeom prst="rect">
-            <a:avLst/>
-          </a:prstGeom>
-          <a:solidFill>
-            <a:srgbClr val="E0E0E0"/>
-          </a:solidFill>
-          <a:ln>
-            <a:noFill/>
-          </a:ln>
-        </p:spPr>
-        <p:style>
-          <a:lnRef idx="1">
-            <a:schemeClr val="accent1"/>
-          </a:lnRef>
-          <a:fillRef idx="3">
-            <a:schemeClr val="accent1"/>
-          </a:fillRef>
-          <a:effectRef idx="2">
-            <a:schemeClr val="accent1"/>
-          </a:effectRef>
-          <a:fontRef idx="minor">
-            <a:schemeClr val="lt1"/>
-          </a:fontRef>
-        </p:style>
-        <p:txBody>
-          <a:bodyPr rtlCol="0" anchor="ctr"/>
-          <a:lstStyle/>
-          <a:p>
-            <a:pPr algn="ctr"/>
-          </a:p>
-        </p:txBody>
-      </p:sp>
-      <p:sp>
-        <p:nvSpPr>
-          <p:cNvPr id="15" name="Rectangle 14"/>
-          <p:cNvSpPr/>
-          <p:nvPr/>
-        </p:nvSpPr>
-        <p:spPr>
-          <a:xfrm>
-            <a:off x="731520" y="1773936"/>
-            <a:ext cx="10725912" cy="27432"/>
-          </a:xfrm>
-          <a:prstGeom prst="rect">
-            <a:avLst/>
-          </a:prstGeom>
-          <a:solidFill>
-            <a:srgbClr val="A93226"/>
-          </a:solidFill>
-          <a:ln>
-            <a:noFill/>
-          </a:ln>
-        </p:spPr>
-        <p:style>
-          <a:lnRef idx="1">
-            <a:schemeClr val="accent1"/>
-          </a:lnRef>
-          <a:fillRef idx="3">
-            <a:schemeClr val="accent1"/>
-          </a:fillRef>
-          <a:effectRef idx="2">
-            <a:schemeClr val="accent1"/>
-          </a:effectRef>
-          <a:fontRef idx="minor">
-            <a:schemeClr val="lt1"/>
-          </a:fontRef>
-        </p:style>
-        <p:txBody>
-          <a:bodyPr rtlCol="0" anchor="ctr"/>
-          <a:lstStyle/>
-          <a:p>
-            <a:pPr algn="ctr"/>
-          </a:p>
-        </p:txBody>
-      </p:sp>
-      <p:sp>
-        <p:nvSpPr>
-          <p:cNvPr id="16" name="Rectangle 15"/>
-          <p:cNvSpPr/>
-          <p:nvPr/>
-        </p:nvSpPr>
-        <p:spPr>
-          <a:xfrm>
-            <a:off x="731520" y="5212080"/>
-            <a:ext cx="10725912" cy="777240"/>
+            <a:off x="731520" y="1737360"/>
+            <a:ext cx="10725912" cy="1170432"/>
           </a:xfrm>
           <a:prstGeom prst="rect">
             <a:avLst/>
@@ -12848,14 +12100,14 @@
       </p:sp>
       <p:sp>
         <p:nvSpPr>
-          <p:cNvPr id="17" name="Rectangle 16"/>
+          <p:cNvPr id="10" name="Rectangle 9"/>
           <p:cNvSpPr/>
           <p:nvPr/>
         </p:nvSpPr>
         <p:spPr>
           <a:xfrm>
-            <a:off x="731520" y="5212080"/>
-            <a:ext cx="64008" cy="777240"/>
+            <a:off x="731520" y="1737360"/>
+            <a:ext cx="64008" cy="1170432"/>
           </a:xfrm>
           <a:prstGeom prst="rect">
             <a:avLst/>
@@ -12891,14 +12143,14 @@
       </p:sp>
       <p:sp>
         <p:nvSpPr>
-          <p:cNvPr id="18" name="TextBox 17"/>
+          <p:cNvPr id="11" name="TextBox 10"/>
           <p:cNvSpPr txBox="1"/>
           <p:nvPr/>
         </p:nvSpPr>
         <p:spPr>
           <a:xfrm>
-            <a:off x="932688" y="5285232"/>
-            <a:ext cx="10360152" cy="630936"/>
+            <a:off x="960120" y="1956816"/>
+            <a:ext cx="1645920" cy="822960"/>
           </a:xfrm>
           <a:prstGeom prst="rect">
             <a:avLst/>
@@ -12906,7 +12158,7 @@
           <a:noFill/>
         </p:spPr>
         <p:txBody>
-          <a:bodyPr wrap="square" anchor="ctr" lIns="18288" rIns="18288">
+          <a:bodyPr wrap="square" anchor="t" lIns="18288" rIns="18288">
             <a:spAutoFit/>
           </a:bodyPr>
           <a:lstStyle/>
@@ -12917,13 +12169,1404 @@
               </a:spcAft>
             </a:pPr>
             <a:r>
-              <a:rPr sz="1150" b="0">
+              <a:rPr sz="1150" b="1">
+                <a:solidFill>
+                  <a:srgbClr val="A93226"/>
+                </a:solidFill>
+                <a:latin typeface="Calibri"/>
+              </a:rPr>
+              <a:t>LAYER 1</a:t>
+            </a:r>
+          </a:p>
+          <a:p>
+            <a:pPr algn="l">
+              <a:spcAft>
+                <a:spcPts val="400"/>
+              </a:spcAft>
+            </a:pPr>
+            <a:r>
+              <a:rPr sz="950" b="0">
                 <a:solidFill>
                   <a:srgbClr val="616161"/>
                 </a:solidFill>
                 <a:latin typeface="Calibri"/>
               </a:rPr>
-              <a:t>Possible difficulties: cloudy satellite images in monsoon months; we will use summer-season images and standard cloud filters.</a:t>
+              <a:t>Data sources</a:t>
+            </a:r>
+          </a:p>
+        </p:txBody>
+      </p:sp>
+      <p:sp>
+        <p:nvSpPr>
+          <p:cNvPr id="12" name="Rounded Rectangle 11"/>
+          <p:cNvSpPr/>
+          <p:nvPr/>
+        </p:nvSpPr>
+        <p:spPr>
+          <a:xfrm>
+            <a:off x="2788920" y="1938528"/>
+            <a:ext cx="1993392" cy="768096"/>
+          </a:xfrm>
+          <a:prstGeom prst="roundRect">
+            <a:avLst/>
+          </a:prstGeom>
+          <a:solidFill>
+            <a:srgbClr val="FFFFFF"/>
+          </a:solidFill>
+          <a:ln w="11430">
+            <a:solidFill>
+              <a:srgbClr val="9E9E9E"/>
+            </a:solidFill>
+          </a:ln>
+        </p:spPr>
+        <p:style>
+          <a:lnRef idx="1">
+            <a:schemeClr val="accent1"/>
+          </a:lnRef>
+          <a:fillRef idx="3">
+            <a:schemeClr val="accent1"/>
+          </a:fillRef>
+          <a:effectRef idx="2">
+            <a:schemeClr val="accent1"/>
+          </a:effectRef>
+          <a:fontRef idx="minor">
+            <a:schemeClr val="lt1"/>
+          </a:fontRef>
+        </p:style>
+        <p:txBody>
+          <a:bodyPr rtlCol="0" anchor="ctr"/>
+          <a:lstStyle/>
+          <a:p>
+            <a:pPr algn="ctr"/>
+          </a:p>
+        </p:txBody>
+      </p:sp>
+      <p:sp>
+        <p:nvSpPr>
+          <p:cNvPr id="13" name="TextBox 12"/>
+          <p:cNvSpPr txBox="1"/>
+          <p:nvPr/>
+        </p:nvSpPr>
+        <p:spPr>
+          <a:xfrm>
+            <a:off x="2862072" y="1956816"/>
+            <a:ext cx="1847088" cy="731520"/>
+          </a:xfrm>
+          <a:prstGeom prst="rect">
+            <a:avLst/>
+          </a:prstGeom>
+          <a:noFill/>
+        </p:spPr>
+        <p:txBody>
+          <a:bodyPr wrap="square" anchor="ctr">
+            <a:spAutoFit/>
+          </a:bodyPr>
+          <a:lstStyle/>
+          <a:p>
+            <a:pPr algn="ctr"/>
+            <a:r>
+              <a:rPr sz="1050" b="1">
+                <a:solidFill>
+                  <a:srgbClr val="212121"/>
+                </a:solidFill>
+                <a:latin typeface="Calibri"/>
+              </a:rPr>
+              <a:t>Landsat 8/9
+thermal (LST)</a:t>
+            </a:r>
+          </a:p>
+        </p:txBody>
+      </p:sp>
+      <p:sp>
+        <p:nvSpPr>
+          <p:cNvPr id="14" name="Rounded Rectangle 13"/>
+          <p:cNvSpPr/>
+          <p:nvPr/>
+        </p:nvSpPr>
+        <p:spPr>
+          <a:xfrm>
+            <a:off x="4946904" y="1938528"/>
+            <a:ext cx="1993392" cy="768096"/>
+          </a:xfrm>
+          <a:prstGeom prst="roundRect">
+            <a:avLst/>
+          </a:prstGeom>
+          <a:solidFill>
+            <a:srgbClr val="FFFFFF"/>
+          </a:solidFill>
+          <a:ln w="11430">
+            <a:solidFill>
+              <a:srgbClr val="9E9E9E"/>
+            </a:solidFill>
+          </a:ln>
+        </p:spPr>
+        <p:style>
+          <a:lnRef idx="1">
+            <a:schemeClr val="accent1"/>
+          </a:lnRef>
+          <a:fillRef idx="3">
+            <a:schemeClr val="accent1"/>
+          </a:fillRef>
+          <a:effectRef idx="2">
+            <a:schemeClr val="accent1"/>
+          </a:effectRef>
+          <a:fontRef idx="minor">
+            <a:schemeClr val="lt1"/>
+          </a:fontRef>
+        </p:style>
+        <p:txBody>
+          <a:bodyPr rtlCol="0" anchor="ctr"/>
+          <a:lstStyle/>
+          <a:p>
+            <a:pPr algn="ctr"/>
+          </a:p>
+        </p:txBody>
+      </p:sp>
+      <p:sp>
+        <p:nvSpPr>
+          <p:cNvPr id="15" name="TextBox 14"/>
+          <p:cNvSpPr txBox="1"/>
+          <p:nvPr/>
+        </p:nvSpPr>
+        <p:spPr>
+          <a:xfrm>
+            <a:off x="5020056" y="1956816"/>
+            <a:ext cx="1847088" cy="731520"/>
+          </a:xfrm>
+          <a:prstGeom prst="rect">
+            <a:avLst/>
+          </a:prstGeom>
+          <a:noFill/>
+        </p:spPr>
+        <p:txBody>
+          <a:bodyPr wrap="square" anchor="ctr">
+            <a:spAutoFit/>
+          </a:bodyPr>
+          <a:lstStyle/>
+          <a:p>
+            <a:pPr algn="ctr"/>
+            <a:r>
+              <a:rPr sz="1050" b="1">
+                <a:solidFill>
+                  <a:srgbClr val="212121"/>
+                </a:solidFill>
+                <a:latin typeface="Calibri"/>
+              </a:rPr>
+              <a:t>Sentinel-2
+land-use images</a:t>
+            </a:r>
+          </a:p>
+        </p:txBody>
+      </p:sp>
+      <p:sp>
+        <p:nvSpPr>
+          <p:cNvPr id="16" name="Rounded Rectangle 15"/>
+          <p:cNvSpPr/>
+          <p:nvPr/>
+        </p:nvSpPr>
+        <p:spPr>
+          <a:xfrm>
+            <a:off x="7104888" y="1938528"/>
+            <a:ext cx="1993392" cy="768096"/>
+          </a:xfrm>
+          <a:prstGeom prst="roundRect">
+            <a:avLst/>
+          </a:prstGeom>
+          <a:solidFill>
+            <a:srgbClr val="FFFFFF"/>
+          </a:solidFill>
+          <a:ln w="11430">
+            <a:solidFill>
+              <a:srgbClr val="9E9E9E"/>
+            </a:solidFill>
+          </a:ln>
+        </p:spPr>
+        <p:style>
+          <a:lnRef idx="1">
+            <a:schemeClr val="accent1"/>
+          </a:lnRef>
+          <a:fillRef idx="3">
+            <a:schemeClr val="accent1"/>
+          </a:fillRef>
+          <a:effectRef idx="2">
+            <a:schemeClr val="accent1"/>
+          </a:effectRef>
+          <a:fontRef idx="minor">
+            <a:schemeClr val="lt1"/>
+          </a:fontRef>
+        </p:style>
+        <p:txBody>
+          <a:bodyPr rtlCol="0" anchor="ctr"/>
+          <a:lstStyle/>
+          <a:p>
+            <a:pPr algn="ctr"/>
+          </a:p>
+        </p:txBody>
+      </p:sp>
+      <p:sp>
+        <p:nvSpPr>
+          <p:cNvPr id="17" name="TextBox 16"/>
+          <p:cNvSpPr txBox="1"/>
+          <p:nvPr/>
+        </p:nvSpPr>
+        <p:spPr>
+          <a:xfrm>
+            <a:off x="7178040" y="1956816"/>
+            <a:ext cx="1847088" cy="731520"/>
+          </a:xfrm>
+          <a:prstGeom prst="rect">
+            <a:avLst/>
+          </a:prstGeom>
+          <a:noFill/>
+        </p:spPr>
+        <p:txBody>
+          <a:bodyPr wrap="square" anchor="ctr">
+            <a:spAutoFit/>
+          </a:bodyPr>
+          <a:lstStyle/>
+          <a:p>
+            <a:pPr algn="ctr"/>
+            <a:r>
+              <a:rPr sz="1050" b="1">
+                <a:solidFill>
+                  <a:srgbClr val="212121"/>
+                </a:solidFill>
+                <a:latin typeface="Calibri"/>
+              </a:rPr>
+              <a:t>MODIS LST
++ IMD records</a:t>
+            </a:r>
+          </a:p>
+        </p:txBody>
+      </p:sp>
+      <p:sp>
+        <p:nvSpPr>
+          <p:cNvPr id="18" name="Rounded Rectangle 17"/>
+          <p:cNvSpPr/>
+          <p:nvPr/>
+        </p:nvSpPr>
+        <p:spPr>
+          <a:xfrm>
+            <a:off x="9262872" y="1938528"/>
+            <a:ext cx="1993392" cy="768096"/>
+          </a:xfrm>
+          <a:prstGeom prst="roundRect">
+            <a:avLst/>
+          </a:prstGeom>
+          <a:solidFill>
+            <a:srgbClr val="FFFFFF"/>
+          </a:solidFill>
+          <a:ln w="11430">
+            <a:solidFill>
+              <a:srgbClr val="9E9E9E"/>
+            </a:solidFill>
+          </a:ln>
+        </p:spPr>
+        <p:style>
+          <a:lnRef idx="1">
+            <a:schemeClr val="accent1"/>
+          </a:lnRef>
+          <a:fillRef idx="3">
+            <a:schemeClr val="accent1"/>
+          </a:fillRef>
+          <a:effectRef idx="2">
+            <a:schemeClr val="accent1"/>
+          </a:effectRef>
+          <a:fontRef idx="minor">
+            <a:schemeClr val="lt1"/>
+          </a:fontRef>
+        </p:style>
+        <p:txBody>
+          <a:bodyPr rtlCol="0" anchor="ctr"/>
+          <a:lstStyle/>
+          <a:p>
+            <a:pPr algn="ctr"/>
+          </a:p>
+        </p:txBody>
+      </p:sp>
+      <p:sp>
+        <p:nvSpPr>
+          <p:cNvPr id="19" name="TextBox 18"/>
+          <p:cNvSpPr txBox="1"/>
+          <p:nvPr/>
+        </p:nvSpPr>
+        <p:spPr>
+          <a:xfrm>
+            <a:off x="9336024" y="1956816"/>
+            <a:ext cx="1847088" cy="731520"/>
+          </a:xfrm>
+          <a:prstGeom prst="rect">
+            <a:avLst/>
+          </a:prstGeom>
+          <a:noFill/>
+        </p:spPr>
+        <p:txBody>
+          <a:bodyPr wrap="square" anchor="ctr">
+            <a:spAutoFit/>
+          </a:bodyPr>
+          <a:lstStyle/>
+          <a:p>
+            <a:pPr algn="ctr"/>
+            <a:r>
+              <a:rPr sz="1050" b="1">
+                <a:solidFill>
+                  <a:srgbClr val="212121"/>
+                </a:solidFill>
+                <a:latin typeface="Calibri"/>
+              </a:rPr>
+              <a:t>Ward / city
+boundary maps</a:t>
+            </a:r>
+          </a:p>
+        </p:txBody>
+      </p:sp>
+      <p:sp>
+        <p:nvSpPr>
+          <p:cNvPr id="20" name="TextBox 19"/>
+          <p:cNvSpPr txBox="1"/>
+          <p:nvPr/>
+        </p:nvSpPr>
+        <p:spPr>
+          <a:xfrm>
+            <a:off x="5760720" y="2935224"/>
+            <a:ext cx="640080" cy="292608"/>
+          </a:xfrm>
+          <a:prstGeom prst="rect">
+            <a:avLst/>
+          </a:prstGeom>
+          <a:noFill/>
+        </p:spPr>
+        <p:txBody>
+          <a:bodyPr wrap="square" anchor="t" lIns="18288" rIns="18288">
+            <a:spAutoFit/>
+          </a:bodyPr>
+          <a:lstStyle/>
+          <a:p>
+            <a:pPr algn="ctr">
+              <a:spcAft>
+                <a:spcPts val="400"/>
+              </a:spcAft>
+            </a:pPr>
+            <a:r>
+              <a:rPr sz="1300" b="1">
+                <a:solidFill>
+                  <a:srgbClr val="9E9E9E"/>
+                </a:solidFill>
+                <a:latin typeface="Calibri"/>
+              </a:rPr>
+              <a:t>▼</a:t>
+            </a:r>
+          </a:p>
+        </p:txBody>
+      </p:sp>
+      <p:sp>
+        <p:nvSpPr>
+          <p:cNvPr id="21" name="Rectangle 20"/>
+          <p:cNvSpPr/>
+          <p:nvPr/>
+        </p:nvSpPr>
+        <p:spPr>
+          <a:xfrm>
+            <a:off x="731520" y="3227832"/>
+            <a:ext cx="10725912" cy="1170432"/>
+          </a:xfrm>
+          <a:prstGeom prst="rect">
+            <a:avLst/>
+          </a:prstGeom>
+          <a:solidFill>
+            <a:srgbClr val="FFFFFF"/>
+          </a:solidFill>
+          <a:ln w="9525">
+            <a:solidFill>
+              <a:srgbClr val="E0E0E0"/>
+            </a:solidFill>
+          </a:ln>
+        </p:spPr>
+        <p:style>
+          <a:lnRef idx="1">
+            <a:schemeClr val="accent1"/>
+          </a:lnRef>
+          <a:fillRef idx="3">
+            <a:schemeClr val="accent1"/>
+          </a:fillRef>
+          <a:effectRef idx="2">
+            <a:schemeClr val="accent1"/>
+          </a:effectRef>
+          <a:fontRef idx="minor">
+            <a:schemeClr val="lt1"/>
+          </a:fontRef>
+        </p:style>
+        <p:txBody>
+          <a:bodyPr rtlCol="0" anchor="ctr"/>
+          <a:lstStyle/>
+          <a:p>
+            <a:pPr algn="ctr"/>
+          </a:p>
+        </p:txBody>
+      </p:sp>
+      <p:sp>
+        <p:nvSpPr>
+          <p:cNvPr id="22" name="Rectangle 21"/>
+          <p:cNvSpPr/>
+          <p:nvPr/>
+        </p:nvSpPr>
+        <p:spPr>
+          <a:xfrm>
+            <a:off x="731520" y="3227832"/>
+            <a:ext cx="64008" cy="1170432"/>
+          </a:xfrm>
+          <a:prstGeom prst="rect">
+            <a:avLst/>
+          </a:prstGeom>
+          <a:solidFill>
+            <a:srgbClr val="A93226"/>
+          </a:solidFill>
+          <a:ln>
+            <a:noFill/>
+          </a:ln>
+        </p:spPr>
+        <p:style>
+          <a:lnRef idx="1">
+            <a:schemeClr val="accent1"/>
+          </a:lnRef>
+          <a:fillRef idx="3">
+            <a:schemeClr val="accent1"/>
+          </a:fillRef>
+          <a:effectRef idx="2">
+            <a:schemeClr val="accent1"/>
+          </a:effectRef>
+          <a:fontRef idx="minor">
+            <a:schemeClr val="lt1"/>
+          </a:fontRef>
+        </p:style>
+        <p:txBody>
+          <a:bodyPr rtlCol="0" anchor="ctr"/>
+          <a:lstStyle/>
+          <a:p>
+            <a:pPr algn="ctr"/>
+          </a:p>
+        </p:txBody>
+      </p:sp>
+      <p:sp>
+        <p:nvSpPr>
+          <p:cNvPr id="23" name="TextBox 22"/>
+          <p:cNvSpPr txBox="1"/>
+          <p:nvPr/>
+        </p:nvSpPr>
+        <p:spPr>
+          <a:xfrm>
+            <a:off x="960120" y="3447288"/>
+            <a:ext cx="1645920" cy="822960"/>
+          </a:xfrm>
+          <a:prstGeom prst="rect">
+            <a:avLst/>
+          </a:prstGeom>
+          <a:noFill/>
+        </p:spPr>
+        <p:txBody>
+          <a:bodyPr wrap="square" anchor="t" lIns="18288" rIns="18288">
+            <a:spAutoFit/>
+          </a:bodyPr>
+          <a:lstStyle/>
+          <a:p>
+            <a:pPr algn="l">
+              <a:spcAft>
+                <a:spcPts val="400"/>
+              </a:spcAft>
+            </a:pPr>
+            <a:r>
+              <a:rPr sz="1150" b="1">
+                <a:solidFill>
+                  <a:srgbClr val="A93226"/>
+                </a:solidFill>
+                <a:latin typeface="Calibri"/>
+              </a:rPr>
+              <a:t>LAYER 2</a:t>
+            </a:r>
+          </a:p>
+          <a:p>
+            <a:pPr algn="l">
+              <a:spcAft>
+                <a:spcPts val="400"/>
+              </a:spcAft>
+            </a:pPr>
+            <a:r>
+              <a:rPr sz="950" b="0">
+                <a:solidFill>
+                  <a:srgbClr val="616161"/>
+                </a:solidFill>
+                <a:latin typeface="Calibri"/>
+              </a:rPr>
+              <a:t>Processing + model</a:t>
+            </a:r>
+          </a:p>
+        </p:txBody>
+      </p:sp>
+      <p:sp>
+        <p:nvSpPr>
+          <p:cNvPr id="24" name="Rounded Rectangle 23"/>
+          <p:cNvSpPr/>
+          <p:nvPr/>
+        </p:nvSpPr>
+        <p:spPr>
+          <a:xfrm>
+            <a:off x="2788920" y="3429000"/>
+            <a:ext cx="1993392" cy="768096"/>
+          </a:xfrm>
+          <a:prstGeom prst="roundRect">
+            <a:avLst/>
+          </a:prstGeom>
+          <a:solidFill>
+            <a:srgbClr val="FFFFFF"/>
+          </a:solidFill>
+          <a:ln w="11430">
+            <a:solidFill>
+              <a:srgbClr val="9E9E9E"/>
+            </a:solidFill>
+          </a:ln>
+        </p:spPr>
+        <p:style>
+          <a:lnRef idx="1">
+            <a:schemeClr val="accent1"/>
+          </a:lnRef>
+          <a:fillRef idx="3">
+            <a:schemeClr val="accent1"/>
+          </a:fillRef>
+          <a:effectRef idx="2">
+            <a:schemeClr val="accent1"/>
+          </a:effectRef>
+          <a:fontRef idx="minor">
+            <a:schemeClr val="lt1"/>
+          </a:fontRef>
+        </p:style>
+        <p:txBody>
+          <a:bodyPr rtlCol="0" anchor="ctr"/>
+          <a:lstStyle/>
+          <a:p>
+            <a:pPr algn="ctr"/>
+          </a:p>
+        </p:txBody>
+      </p:sp>
+      <p:sp>
+        <p:nvSpPr>
+          <p:cNvPr id="25" name="TextBox 24"/>
+          <p:cNvSpPr txBox="1"/>
+          <p:nvPr/>
+        </p:nvSpPr>
+        <p:spPr>
+          <a:xfrm>
+            <a:off x="2862072" y="3447288"/>
+            <a:ext cx="1847088" cy="731520"/>
+          </a:xfrm>
+          <a:prstGeom prst="rect">
+            <a:avLst/>
+          </a:prstGeom>
+          <a:noFill/>
+        </p:spPr>
+        <p:txBody>
+          <a:bodyPr wrap="square" anchor="ctr">
+            <a:spAutoFit/>
+          </a:bodyPr>
+          <a:lstStyle/>
+          <a:p>
+            <a:pPr algn="ctr"/>
+            <a:r>
+              <a:rPr sz="1050" b="1">
+                <a:solidFill>
+                  <a:srgbClr val="212121"/>
+                </a:solidFill>
+                <a:latin typeface="Calibri"/>
+              </a:rPr>
+              <a:t>Clean + align
+data (GEE)</a:t>
+            </a:r>
+          </a:p>
+        </p:txBody>
+      </p:sp>
+      <p:sp>
+        <p:nvSpPr>
+          <p:cNvPr id="26" name="Rounded Rectangle 25"/>
+          <p:cNvSpPr/>
+          <p:nvPr/>
+        </p:nvSpPr>
+        <p:spPr>
+          <a:xfrm>
+            <a:off x="4946904" y="3429000"/>
+            <a:ext cx="1993392" cy="768096"/>
+          </a:xfrm>
+          <a:prstGeom prst="roundRect">
+            <a:avLst/>
+          </a:prstGeom>
+          <a:solidFill>
+            <a:srgbClr val="FFFFFF"/>
+          </a:solidFill>
+          <a:ln w="11430">
+            <a:solidFill>
+              <a:srgbClr val="9E9E9E"/>
+            </a:solidFill>
+          </a:ln>
+        </p:spPr>
+        <p:style>
+          <a:lnRef idx="1">
+            <a:schemeClr val="accent1"/>
+          </a:lnRef>
+          <a:fillRef idx="3">
+            <a:schemeClr val="accent1"/>
+          </a:fillRef>
+          <a:effectRef idx="2">
+            <a:schemeClr val="accent1"/>
+          </a:effectRef>
+          <a:fontRef idx="minor">
+            <a:schemeClr val="lt1"/>
+          </a:fontRef>
+        </p:style>
+        <p:txBody>
+          <a:bodyPr rtlCol="0" anchor="ctr"/>
+          <a:lstStyle/>
+          <a:p>
+            <a:pPr algn="ctr"/>
+          </a:p>
+        </p:txBody>
+      </p:sp>
+      <p:sp>
+        <p:nvSpPr>
+          <p:cNvPr id="27" name="TextBox 26"/>
+          <p:cNvSpPr txBox="1"/>
+          <p:nvPr/>
+        </p:nvSpPr>
+        <p:spPr>
+          <a:xfrm>
+            <a:off x="5020056" y="3447288"/>
+            <a:ext cx="1847088" cy="731520"/>
+          </a:xfrm>
+          <a:prstGeom prst="rect">
+            <a:avLst/>
+          </a:prstGeom>
+          <a:noFill/>
+        </p:spPr>
+        <p:txBody>
+          <a:bodyPr wrap="square" anchor="ctr">
+            <a:spAutoFit/>
+          </a:bodyPr>
+          <a:lstStyle/>
+          <a:p>
+            <a:pPr algn="ctr"/>
+            <a:r>
+              <a:rPr sz="1050" b="1">
+                <a:solidFill>
+                  <a:srgbClr val="212121"/>
+                </a:solidFill>
+                <a:latin typeface="Calibri"/>
+              </a:rPr>
+              <a:t>Build features:
+NDVI, NDBI…</a:t>
+            </a:r>
+          </a:p>
+        </p:txBody>
+      </p:sp>
+      <p:sp>
+        <p:nvSpPr>
+          <p:cNvPr id="28" name="Rounded Rectangle 27"/>
+          <p:cNvSpPr/>
+          <p:nvPr/>
+        </p:nvSpPr>
+        <p:spPr>
+          <a:xfrm>
+            <a:off x="7104888" y="3429000"/>
+            <a:ext cx="1993392" cy="768096"/>
+          </a:xfrm>
+          <a:prstGeom prst="roundRect">
+            <a:avLst/>
+          </a:prstGeom>
+          <a:solidFill>
+            <a:srgbClr val="FFFFFF"/>
+          </a:solidFill>
+          <a:ln w="11430">
+            <a:solidFill>
+              <a:srgbClr val="9E9E9E"/>
+            </a:solidFill>
+          </a:ln>
+        </p:spPr>
+        <p:style>
+          <a:lnRef idx="1">
+            <a:schemeClr val="accent1"/>
+          </a:lnRef>
+          <a:fillRef idx="3">
+            <a:schemeClr val="accent1"/>
+          </a:fillRef>
+          <a:effectRef idx="2">
+            <a:schemeClr val="accent1"/>
+          </a:effectRef>
+          <a:fontRef idx="minor">
+            <a:schemeClr val="lt1"/>
+          </a:fontRef>
+        </p:style>
+        <p:txBody>
+          <a:bodyPr rtlCol="0" anchor="ctr"/>
+          <a:lstStyle/>
+          <a:p>
+            <a:pPr algn="ctr"/>
+          </a:p>
+        </p:txBody>
+      </p:sp>
+      <p:sp>
+        <p:nvSpPr>
+          <p:cNvPr id="29" name="TextBox 28"/>
+          <p:cNvSpPr txBox="1"/>
+          <p:nvPr/>
+        </p:nvSpPr>
+        <p:spPr>
+          <a:xfrm>
+            <a:off x="7178040" y="3447288"/>
+            <a:ext cx="1847088" cy="731520"/>
+          </a:xfrm>
+          <a:prstGeom prst="rect">
+            <a:avLst/>
+          </a:prstGeom>
+          <a:noFill/>
+        </p:spPr>
+        <p:txBody>
+          <a:bodyPr wrap="square" anchor="ctr">
+            <a:spAutoFit/>
+          </a:bodyPr>
+          <a:lstStyle/>
+          <a:p>
+            <a:pPr algn="ctr"/>
+            <a:r>
+              <a:rPr sz="1050" b="1">
+                <a:solidFill>
+                  <a:srgbClr val="212121"/>
+                </a:solidFill>
+                <a:latin typeface="Calibri"/>
+              </a:rPr>
+              <a:t>Train ML model
+(RF / XGBoost)</a:t>
+            </a:r>
+          </a:p>
+        </p:txBody>
+      </p:sp>
+      <p:sp>
+        <p:nvSpPr>
+          <p:cNvPr id="30" name="Rounded Rectangle 29"/>
+          <p:cNvSpPr/>
+          <p:nvPr/>
+        </p:nvSpPr>
+        <p:spPr>
+          <a:xfrm>
+            <a:off x="9262872" y="3429000"/>
+            <a:ext cx="1993392" cy="768096"/>
+          </a:xfrm>
+          <a:prstGeom prst="roundRect">
+            <a:avLst/>
+          </a:prstGeom>
+          <a:solidFill>
+            <a:srgbClr val="FFFFFF"/>
+          </a:solidFill>
+          <a:ln w="11430">
+            <a:solidFill>
+              <a:srgbClr val="9E9E9E"/>
+            </a:solidFill>
+          </a:ln>
+        </p:spPr>
+        <p:style>
+          <a:lnRef idx="1">
+            <a:schemeClr val="accent1"/>
+          </a:lnRef>
+          <a:fillRef idx="3">
+            <a:schemeClr val="accent1"/>
+          </a:fillRef>
+          <a:effectRef idx="2">
+            <a:schemeClr val="accent1"/>
+          </a:effectRef>
+          <a:fontRef idx="minor">
+            <a:schemeClr val="lt1"/>
+          </a:fontRef>
+        </p:style>
+        <p:txBody>
+          <a:bodyPr rtlCol="0" anchor="ctr"/>
+          <a:lstStyle/>
+          <a:p>
+            <a:pPr algn="ctr"/>
+          </a:p>
+        </p:txBody>
+      </p:sp>
+      <p:sp>
+        <p:nvSpPr>
+          <p:cNvPr id="31" name="TextBox 30"/>
+          <p:cNvSpPr txBox="1"/>
+          <p:nvPr/>
+        </p:nvSpPr>
+        <p:spPr>
+          <a:xfrm>
+            <a:off x="9336024" y="3447288"/>
+            <a:ext cx="1847088" cy="731520"/>
+          </a:xfrm>
+          <a:prstGeom prst="rect">
+            <a:avLst/>
+          </a:prstGeom>
+          <a:noFill/>
+        </p:spPr>
+        <p:txBody>
+          <a:bodyPr wrap="square" anchor="ctr">
+            <a:spAutoFit/>
+          </a:bodyPr>
+          <a:lstStyle/>
+          <a:p>
+            <a:pPr algn="ctr"/>
+            <a:r>
+              <a:rPr sz="1050" b="1">
+                <a:solidFill>
+                  <a:srgbClr val="212121"/>
+                </a:solidFill>
+                <a:latin typeface="Calibri"/>
+              </a:rPr>
+              <a:t>Forecast
+2030 hotspots</a:t>
+            </a:r>
+          </a:p>
+        </p:txBody>
+      </p:sp>
+      <p:sp>
+        <p:nvSpPr>
+          <p:cNvPr id="32" name="TextBox 31"/>
+          <p:cNvSpPr txBox="1"/>
+          <p:nvPr/>
+        </p:nvSpPr>
+        <p:spPr>
+          <a:xfrm>
+            <a:off x="5760720" y="4425696"/>
+            <a:ext cx="640080" cy="292608"/>
+          </a:xfrm>
+          <a:prstGeom prst="rect">
+            <a:avLst/>
+          </a:prstGeom>
+          <a:noFill/>
+        </p:spPr>
+        <p:txBody>
+          <a:bodyPr wrap="square" anchor="t" lIns="18288" rIns="18288">
+            <a:spAutoFit/>
+          </a:bodyPr>
+          <a:lstStyle/>
+          <a:p>
+            <a:pPr algn="ctr">
+              <a:spcAft>
+                <a:spcPts val="400"/>
+              </a:spcAft>
+            </a:pPr>
+            <a:r>
+              <a:rPr sz="1300" b="1">
+                <a:solidFill>
+                  <a:srgbClr val="9E9E9E"/>
+                </a:solidFill>
+                <a:latin typeface="Calibri"/>
+              </a:rPr>
+              <a:t>▼</a:t>
+            </a:r>
+          </a:p>
+        </p:txBody>
+      </p:sp>
+      <p:sp>
+        <p:nvSpPr>
+          <p:cNvPr id="33" name="Rectangle 32"/>
+          <p:cNvSpPr/>
+          <p:nvPr/>
+        </p:nvSpPr>
+        <p:spPr>
+          <a:xfrm>
+            <a:off x="731520" y="4718304"/>
+            <a:ext cx="10725912" cy="1170432"/>
+          </a:xfrm>
+          <a:prstGeom prst="rect">
+            <a:avLst/>
+          </a:prstGeom>
+          <a:solidFill>
+            <a:srgbClr val="F5F5F5"/>
+          </a:solidFill>
+          <a:ln w="9525">
+            <a:solidFill>
+              <a:srgbClr val="E0E0E0"/>
+            </a:solidFill>
+          </a:ln>
+        </p:spPr>
+        <p:style>
+          <a:lnRef idx="1">
+            <a:schemeClr val="accent1"/>
+          </a:lnRef>
+          <a:fillRef idx="3">
+            <a:schemeClr val="accent1"/>
+          </a:fillRef>
+          <a:effectRef idx="2">
+            <a:schemeClr val="accent1"/>
+          </a:effectRef>
+          <a:fontRef idx="minor">
+            <a:schemeClr val="lt1"/>
+          </a:fontRef>
+        </p:style>
+        <p:txBody>
+          <a:bodyPr rtlCol="0" anchor="ctr"/>
+          <a:lstStyle/>
+          <a:p>
+            <a:pPr algn="ctr"/>
+          </a:p>
+        </p:txBody>
+      </p:sp>
+      <p:sp>
+        <p:nvSpPr>
+          <p:cNvPr id="34" name="Rectangle 33"/>
+          <p:cNvSpPr/>
+          <p:nvPr/>
+        </p:nvSpPr>
+        <p:spPr>
+          <a:xfrm>
+            <a:off x="731520" y="4718304"/>
+            <a:ext cx="64008" cy="1170432"/>
+          </a:xfrm>
+          <a:prstGeom prst="rect">
+            <a:avLst/>
+          </a:prstGeom>
+          <a:solidFill>
+            <a:srgbClr val="A93226"/>
+          </a:solidFill>
+          <a:ln>
+            <a:noFill/>
+          </a:ln>
+        </p:spPr>
+        <p:style>
+          <a:lnRef idx="1">
+            <a:schemeClr val="accent1"/>
+          </a:lnRef>
+          <a:fillRef idx="3">
+            <a:schemeClr val="accent1"/>
+          </a:fillRef>
+          <a:effectRef idx="2">
+            <a:schemeClr val="accent1"/>
+          </a:effectRef>
+          <a:fontRef idx="minor">
+            <a:schemeClr val="lt1"/>
+          </a:fontRef>
+        </p:style>
+        <p:txBody>
+          <a:bodyPr rtlCol="0" anchor="ctr"/>
+          <a:lstStyle/>
+          <a:p>
+            <a:pPr algn="ctr"/>
+          </a:p>
+        </p:txBody>
+      </p:sp>
+      <p:sp>
+        <p:nvSpPr>
+          <p:cNvPr id="35" name="TextBox 34"/>
+          <p:cNvSpPr txBox="1"/>
+          <p:nvPr/>
+        </p:nvSpPr>
+        <p:spPr>
+          <a:xfrm>
+            <a:off x="960120" y="4937760"/>
+            <a:ext cx="1645920" cy="822960"/>
+          </a:xfrm>
+          <a:prstGeom prst="rect">
+            <a:avLst/>
+          </a:prstGeom>
+          <a:noFill/>
+        </p:spPr>
+        <p:txBody>
+          <a:bodyPr wrap="square" anchor="t" lIns="18288" rIns="18288">
+            <a:spAutoFit/>
+          </a:bodyPr>
+          <a:lstStyle/>
+          <a:p>
+            <a:pPr algn="l">
+              <a:spcAft>
+                <a:spcPts val="400"/>
+              </a:spcAft>
+            </a:pPr>
+            <a:r>
+              <a:rPr sz="1150" b="1">
+                <a:solidFill>
+                  <a:srgbClr val="A93226"/>
+                </a:solidFill>
+                <a:latin typeface="Calibri"/>
+              </a:rPr>
+              <a:t>LAYER 3</a:t>
+            </a:r>
+          </a:p>
+          <a:p>
+            <a:pPr algn="l">
+              <a:spcAft>
+                <a:spcPts val="400"/>
+              </a:spcAft>
+            </a:pPr>
+            <a:r>
+              <a:rPr sz="950" b="0">
+                <a:solidFill>
+                  <a:srgbClr val="616161"/>
+                </a:solidFill>
+                <a:latin typeface="Calibri"/>
+              </a:rPr>
+              <a:t>Outputs + users</a:t>
+            </a:r>
+          </a:p>
+        </p:txBody>
+      </p:sp>
+      <p:sp>
+        <p:nvSpPr>
+          <p:cNvPr id="36" name="Rounded Rectangle 35"/>
+          <p:cNvSpPr/>
+          <p:nvPr/>
+        </p:nvSpPr>
+        <p:spPr>
+          <a:xfrm>
+            <a:off x="2788920" y="4919472"/>
+            <a:ext cx="1993392" cy="768096"/>
+          </a:xfrm>
+          <a:prstGeom prst="roundRect">
+            <a:avLst/>
+          </a:prstGeom>
+          <a:solidFill>
+            <a:srgbClr val="FFFFFF"/>
+          </a:solidFill>
+          <a:ln w="11430">
+            <a:solidFill>
+              <a:srgbClr val="9E9E9E"/>
+            </a:solidFill>
+          </a:ln>
+        </p:spPr>
+        <p:style>
+          <a:lnRef idx="1">
+            <a:schemeClr val="accent1"/>
+          </a:lnRef>
+          <a:fillRef idx="3">
+            <a:schemeClr val="accent1"/>
+          </a:fillRef>
+          <a:effectRef idx="2">
+            <a:schemeClr val="accent1"/>
+          </a:effectRef>
+          <a:fontRef idx="minor">
+            <a:schemeClr val="lt1"/>
+          </a:fontRef>
+        </p:style>
+        <p:txBody>
+          <a:bodyPr rtlCol="0" anchor="ctr"/>
+          <a:lstStyle/>
+          <a:p>
+            <a:pPr algn="ctr"/>
+          </a:p>
+        </p:txBody>
+      </p:sp>
+      <p:sp>
+        <p:nvSpPr>
+          <p:cNvPr id="37" name="TextBox 36"/>
+          <p:cNvSpPr txBox="1"/>
+          <p:nvPr/>
+        </p:nvSpPr>
+        <p:spPr>
+          <a:xfrm>
+            <a:off x="2862072" y="4937760"/>
+            <a:ext cx="1847088" cy="731520"/>
+          </a:xfrm>
+          <a:prstGeom prst="rect">
+            <a:avLst/>
+          </a:prstGeom>
+          <a:noFill/>
+        </p:spPr>
+        <p:txBody>
+          <a:bodyPr wrap="square" anchor="ctr">
+            <a:spAutoFit/>
+          </a:bodyPr>
+          <a:lstStyle/>
+          <a:p>
+            <a:pPr algn="ctr"/>
+            <a:r>
+              <a:rPr sz="1050" b="1">
+                <a:solidFill>
+                  <a:srgbClr val="212121"/>
+                </a:solidFill>
+                <a:latin typeface="Calibri"/>
+              </a:rPr>
+              <a:t>Hotspot maps
+(GIS layers)</a:t>
+            </a:r>
+          </a:p>
+        </p:txBody>
+      </p:sp>
+      <p:sp>
+        <p:nvSpPr>
+          <p:cNvPr id="38" name="Rounded Rectangle 37"/>
+          <p:cNvSpPr/>
+          <p:nvPr/>
+        </p:nvSpPr>
+        <p:spPr>
+          <a:xfrm>
+            <a:off x="4946904" y="4919472"/>
+            <a:ext cx="1993392" cy="768096"/>
+          </a:xfrm>
+          <a:prstGeom prst="roundRect">
+            <a:avLst/>
+          </a:prstGeom>
+          <a:solidFill>
+            <a:srgbClr val="FFFFFF"/>
+          </a:solidFill>
+          <a:ln w="11430">
+            <a:solidFill>
+              <a:srgbClr val="9E9E9E"/>
+            </a:solidFill>
+          </a:ln>
+        </p:spPr>
+        <p:style>
+          <a:lnRef idx="1">
+            <a:schemeClr val="accent1"/>
+          </a:lnRef>
+          <a:fillRef idx="3">
+            <a:schemeClr val="accent1"/>
+          </a:fillRef>
+          <a:effectRef idx="2">
+            <a:schemeClr val="accent1"/>
+          </a:effectRef>
+          <a:fontRef idx="minor">
+            <a:schemeClr val="lt1"/>
+          </a:fontRef>
+        </p:style>
+        <p:txBody>
+          <a:bodyPr rtlCol="0" anchor="ctr"/>
+          <a:lstStyle/>
+          <a:p>
+            <a:pPr algn="ctr"/>
+          </a:p>
+        </p:txBody>
+      </p:sp>
+      <p:sp>
+        <p:nvSpPr>
+          <p:cNvPr id="39" name="TextBox 38"/>
+          <p:cNvSpPr txBox="1"/>
+          <p:nvPr/>
+        </p:nvSpPr>
+        <p:spPr>
+          <a:xfrm>
+            <a:off x="5020056" y="4937760"/>
+            <a:ext cx="1847088" cy="731520"/>
+          </a:xfrm>
+          <a:prstGeom prst="rect">
+            <a:avLst/>
+          </a:prstGeom>
+          <a:noFill/>
+        </p:spPr>
+        <p:txBody>
+          <a:bodyPr wrap="square" anchor="ctr">
+            <a:spAutoFit/>
+          </a:bodyPr>
+          <a:lstStyle/>
+          <a:p>
+            <a:pPr algn="ctr"/>
+            <a:r>
+              <a:rPr sz="1050" b="1">
+                <a:solidFill>
+                  <a:srgbClr val="212121"/>
+                </a:solidFill>
+                <a:latin typeface="Calibri"/>
+              </a:rPr>
+              <a:t>Ward heat-risk
+tables</a:t>
+            </a:r>
+          </a:p>
+        </p:txBody>
+      </p:sp>
+      <p:sp>
+        <p:nvSpPr>
+          <p:cNvPr id="40" name="Rounded Rectangle 39"/>
+          <p:cNvSpPr/>
+          <p:nvPr/>
+        </p:nvSpPr>
+        <p:spPr>
+          <a:xfrm>
+            <a:off x="7104888" y="4919472"/>
+            <a:ext cx="1993392" cy="768096"/>
+          </a:xfrm>
+          <a:prstGeom prst="roundRect">
+            <a:avLst/>
+          </a:prstGeom>
+          <a:solidFill>
+            <a:srgbClr val="FFFFFF"/>
+          </a:solidFill>
+          <a:ln w="11430">
+            <a:solidFill>
+              <a:srgbClr val="9E9E9E"/>
+            </a:solidFill>
+          </a:ln>
+        </p:spPr>
+        <p:style>
+          <a:lnRef idx="1">
+            <a:schemeClr val="accent1"/>
+          </a:lnRef>
+          <a:fillRef idx="3">
+            <a:schemeClr val="accent1"/>
+          </a:fillRef>
+          <a:effectRef idx="2">
+            <a:schemeClr val="accent1"/>
+          </a:effectRef>
+          <a:fontRef idx="minor">
+            <a:schemeClr val="lt1"/>
+          </a:fontRef>
+        </p:style>
+        <p:txBody>
+          <a:bodyPr rtlCol="0" anchor="ctr"/>
+          <a:lstStyle/>
+          <a:p>
+            <a:pPr algn="ctr"/>
+          </a:p>
+        </p:txBody>
+      </p:sp>
+      <p:sp>
+        <p:nvSpPr>
+          <p:cNvPr id="41" name="TextBox 40"/>
+          <p:cNvSpPr txBox="1"/>
+          <p:nvPr/>
+        </p:nvSpPr>
+        <p:spPr>
+          <a:xfrm>
+            <a:off x="7178040" y="4937760"/>
+            <a:ext cx="1847088" cy="731520"/>
+          </a:xfrm>
+          <a:prstGeom prst="rect">
+            <a:avLst/>
+          </a:prstGeom>
+          <a:noFill/>
+        </p:spPr>
+        <p:txBody>
+          <a:bodyPr wrap="square" anchor="ctr">
+            <a:spAutoFit/>
+          </a:bodyPr>
+          <a:lstStyle/>
+          <a:p>
+            <a:pPr algn="ctr"/>
+            <a:r>
+              <a:rPr sz="1050" b="1">
+                <a:solidFill>
+                  <a:srgbClr val="212121"/>
+                </a:solidFill>
+                <a:latin typeface="Calibri"/>
+              </a:rPr>
+              <a:t>Ward action
+notes</a:t>
+            </a:r>
+          </a:p>
+        </p:txBody>
+      </p:sp>
+      <p:sp>
+        <p:nvSpPr>
+          <p:cNvPr id="42" name="Rounded Rectangle 41"/>
+          <p:cNvSpPr/>
+          <p:nvPr/>
+        </p:nvSpPr>
+        <p:spPr>
+          <a:xfrm>
+            <a:off x="9262872" y="4919472"/>
+            <a:ext cx="1993392" cy="768096"/>
+          </a:xfrm>
+          <a:prstGeom prst="roundRect">
+            <a:avLst/>
+          </a:prstGeom>
+          <a:solidFill>
+            <a:srgbClr val="FFFFFF"/>
+          </a:solidFill>
+          <a:ln w="11430">
+            <a:solidFill>
+              <a:srgbClr val="9E9E9E"/>
+            </a:solidFill>
+          </a:ln>
+        </p:spPr>
+        <p:style>
+          <a:lnRef idx="1">
+            <a:schemeClr val="accent1"/>
+          </a:lnRef>
+          <a:fillRef idx="3">
+            <a:schemeClr val="accent1"/>
+          </a:fillRef>
+          <a:effectRef idx="2">
+            <a:schemeClr val="accent1"/>
+          </a:effectRef>
+          <a:fontRef idx="minor">
+            <a:schemeClr val="lt1"/>
+          </a:fontRef>
+        </p:style>
+        <p:txBody>
+          <a:bodyPr rtlCol="0" anchor="ctr"/>
+          <a:lstStyle/>
+          <a:p>
+            <a:pPr algn="ctr"/>
+          </a:p>
+        </p:txBody>
+      </p:sp>
+      <p:sp>
+        <p:nvSpPr>
+          <p:cNvPr id="43" name="TextBox 42"/>
+          <p:cNvSpPr txBox="1"/>
+          <p:nvPr/>
+        </p:nvSpPr>
+        <p:spPr>
+          <a:xfrm>
+            <a:off x="9336024" y="4937760"/>
+            <a:ext cx="1847088" cy="731520"/>
+          </a:xfrm>
+          <a:prstGeom prst="rect">
+            <a:avLst/>
+          </a:prstGeom>
+          <a:noFill/>
+        </p:spPr>
+        <p:txBody>
+          <a:bodyPr wrap="square" anchor="ctr">
+            <a:spAutoFit/>
+          </a:bodyPr>
+          <a:lstStyle/>
+          <a:p>
+            <a:pPr algn="ctr"/>
+            <a:r>
+              <a:rPr sz="1050" b="1">
+                <a:solidFill>
+                  <a:srgbClr val="212121"/>
+                </a:solidFill>
+                <a:latin typeface="Calibri"/>
+              </a:rPr>
+              <a:t>City heat-plan
+report</a:t>
+            </a:r>
+          </a:p>
+        </p:txBody>
+      </p:sp>
+      <p:sp>
+        <p:nvSpPr>
+          <p:cNvPr id="44" name="TextBox 43"/>
+          <p:cNvSpPr txBox="1"/>
+          <p:nvPr/>
+        </p:nvSpPr>
+        <p:spPr>
+          <a:xfrm>
+            <a:off x="731520" y="6007608"/>
+            <a:ext cx="10725912" cy="320040"/>
+          </a:xfrm>
+          <a:prstGeom prst="rect">
+            <a:avLst/>
+          </a:prstGeom>
+          <a:noFill/>
+        </p:spPr>
+        <p:txBody>
+          <a:bodyPr wrap="square" anchor="t" lIns="18288" rIns="18288">
+            <a:spAutoFit/>
+          </a:bodyPr>
+          <a:lstStyle/>
+          <a:p>
+            <a:pPr algn="l">
+              <a:spcAft>
+                <a:spcPts val="400"/>
+              </a:spcAft>
+            </a:pPr>
+            <a:r>
+              <a:rPr sz="1050" b="0">
+                <a:solidFill>
+                  <a:srgbClr val="616161"/>
+                </a:solidFill>
+                <a:latin typeface="Calibri"/>
+              </a:rPr>
+              <a:t>Build order:  data pipeline  →  model  →  outputs  →  field testing    ·    Pilot on one city first (about 7 weeks)</a:t>
             </a:r>
           </a:p>
         </p:txBody>

</xml_diff>